<commit_message>
Actualizar presentación: Empatía (octubre) marcada como en curso
</commit_message>
<xml_diff>
--- a/Crecer_juntos_talleres_socioemocionales.pptx
+++ b/Crecer_juntos_talleres_socioemocionales.pptx
@@ -697,7 +697,7 @@
               <a:t>GUION ORAL (2 minutos):
 Este es el recorrido que hemos hecho durante el año. En abril trabajamos la convivencia y el respeto: normas básicas de cortesía y tratarnos con amabilidad. En mayo, el autocuidado y la sexualidad, enfocado en límites corporales y protección. En junio, la frustración y el control de impulsos: aprender a esperar turnos y pensar antes de actuar.
 En agosto, «Encuentro la calma»: identificar cómo se siente la calma en el cuerpo y usar estrategias sencillas. En septiembre, la autoestima: reconocer cualidades personales y valorarse como único.
-Octubre corresponde a Empatía. Según la planificación, el objetivo es reconocer y validar las emociones de los compañeros. El estado exacto de implementación lo confirmaremos con el equipo, por lo que por ahora no lo marcamos como completamente realizado.
+Octubre corresponde a Empatía. El objetivo es reconocer y validar las emociones de los compañeros. Este taller se está realizando actualmente.
 Noviembre será el taller de Trabajo en equipo, que aún no se ha realizado; lo presentamos como próximo.
 (Tiempo: ~1 min 45 seg. Señalar visualmente la diferencia entre lo realizado y lo próximo.)</a:t>
             </a:r>
@@ -975,7 +975,7 @@
               <a:t>GUION ORAL (2 minutos):
 En septiembre trabajamos la autoestima. El objetivo fue que los niños y niñas reconozcan sus cualidades personales y se valoren como alguien único.
 Un detalle concreto que sí pudimos verificar es la sesión «Yo puedo». En ella, los niños identificaron, mediante tarjetas, acciones que ya logran hacer por sí mismos. Conversaron sobre cómo aprendieron, quién los ayudó y cómo se sienten al conseguirlo. El cierre destacó que cada niño aprende a su ritmo y que todos tienen logros valiosos.
-En octubre el tema es Empatía: reconocer y validar las emociones de los compañeros. Usamos el objetivo general de la planificación. El estado exacto de las actividades de aula lo confirmaremos con las educadoras y la psicóloga antes de presentarlo como completamente realizado.
+En octubre el tema es Empatía: reconocer y validar las emociones de los compañeros. Este taller se está realizando actualmente en los cursos.
 (Tiempo: ~1 min 50 seg. Mencionar el ejemplo de «Yo puedo» con naturalidad.)</a:t>
             </a:r>
             <a:endParaRPr lang="en-US" dirty="0"/>
@@ -1263,7 +1263,7 @@
 - Detalle verificado: Sesión «Yo puedo» de la planificación de Mi autoestima.
 - Otras planificaciones individuales (Convivencia, Autocuidado, Encuentro la calma, Empatía) no fueron accesibles en su totalidad; se usaron los objetivos de la planificación general.
 - Frustración y control de impulsos: implementado por educadoras según objetivo general; no se atribuye actividad específica.
-- Empatía (octubre): estado de implementación por confirmar con el equipo (psicóloga y educadoras).
+- Empatía (octubre): se está realizando actualmente (confirmado).
 - Trabajo en equipo (noviembre): presentado únicamente como próximo taller.
 - No se inventaron dinámicas, materiales, testimonios ni resultados no documentados.
 - QR de encuesta: https://forms.gle/x8dwJZPQ18cQcSy7A
@@ -3300,17 +3300,17 @@
               <a:buNone/>
             </a:pPr>
             <a:r>
-              <a:rPr lang="en-US" sz="900" dirty="0">
-                <a:solidFill>
-                  <a:srgbClr val="3D405B"/>
-                </a:solidFill>
-                <a:latin typeface="Arial" pitchFamily="34" charset="0"/>
-                <a:ea typeface="Arial" pitchFamily="34" charset="-122"/>
-                <a:cs typeface="Arial" pitchFamily="34" charset="-120"/>
-              </a:rPr>
-              <a:t>A confirmar</a:t>
-            </a:r>
-            <a:endParaRPr lang="en-US" sz="900" dirty="0"/>
+              <a:rPr lang="en-US" sz="1000" b="1" dirty="0">
+                <a:solidFill>
+                  <a:srgbClr val="E07A5F"/>
+                </a:solidFill>
+                <a:latin typeface="Arial" pitchFamily="34" charset="0"/>
+                <a:ea typeface="Arial" pitchFamily="34" charset="-122"/>
+                <a:cs typeface="Arial" pitchFamily="34" charset="-120"/>
+              </a:rPr>
+              <a:t>En curso</a:t>
+            </a:r>
+            <a:endParaRPr lang="en-US" sz="1000" dirty="0"/>
           </a:p>
         </p:txBody>
       </p:sp>
@@ -3503,7 +3503,7 @@
                 <a:ea typeface="Arial" pitchFamily="34" charset="-122"/>
                 <a:cs typeface="Arial" pitchFamily="34" charset="-120"/>
               </a:rPr>
-              <a:t>Los temas en verde ya se trabajaron. Empatía (octubre) está en curso o por confirmar. Trabajo en equipo es el próximo taller.</a:t>
+              <a:t>Los temas en verde ya se trabajaron. Empatía (octubre) se está realizando actualmente. Trabajo en equipo es el próximo taller.</a:t>
             </a:r>
             <a:endParaRPr lang="en-US" sz="1200" dirty="0"/>
           </a:p>
@@ -5421,7 +5421,7 @@
                 <a:ea typeface="Arial" pitchFamily="34" charset="-122"/>
                 <a:cs typeface="Arial" pitchFamily="34" charset="-120"/>
               </a:rPr>
-              <a:t>Estado de implementación</a:t>
+              <a:t>Se está trabajando</a:t>
             </a:r>
             <a:endParaRPr lang="en-US" sz="1200" dirty="0"/>
           </a:p>
@@ -5438,7 +5438,7 @@
                 <a:ea typeface="Arial" pitchFamily="34" charset="-122"/>
                 <a:cs typeface="Arial" pitchFamily="34" charset="-120"/>
               </a:rPr>
-              <a:t>por confirmar con el equipo.</a:t>
+              <a:t>actualmente en los cursos.</a:t>
             </a:r>
             <a:endParaRPr lang="en-US" sz="1200" dirty="0"/>
           </a:p>

</xml_diff>